<commit_message>
data: expand demo catalogue to 30 products, raise budget to 120k
- data/inventory_seed.csv: 10 -> 30 products across grocery, beverages,
  household and higher-value goods, for a fuller, more realistic demo.
- model/config.json: monthly_budget 30k -> 120k so the larger catalogue runs
  cleanly while still showing genuine blocks.
- A typical batch now routes ~21 auto / 6 escalated / 3 blocked (70% auto).
- Update test, refreshed screenshots, deck chart (21/6/3) + PDF, demo script.

All 24 tests pass.

Co-Authored-By: Claude Opus 4.8 <noreply@anthropic.com>
Claude-Session: https://claude.ai/code/session_0171iqArhutXUNMcpmsCmd4n
</commit_message>
<xml_diff>
--- a/docs/ReStock_AI_Presentation.pptx
+++ b/docs/ReStock_AI_Presentation.pptx
@@ -308,13 +308,13 @@
               <c:numCache>
                 <c:ptCount val="3"/>
                 <c:pt idx="0">
-                  <c:v>5</c:v>
+                  <c:v>21</c:v>
                 </c:pt>
                 <c:pt idx="1">
-                  <c:v>3</c:v>
+                  <c:v>6</c:v>
                 </c:pt>
                 <c:pt idx="2">
-                  <c:v>2</c:v>
+                  <c:v>3</c:v>
                 </c:pt>
               </c:numCache>
             </c:numRef>
@@ -2686,7 +2686,7 @@
                 <a:ea typeface="Calibri" pitchFamily="34" charset="-122"/>
                 <a:cs typeface="Calibri" pitchFamily="34" charset="-120"/>
               </a:rPr>
-              <a:t>50%</a:t>
+              <a:t>70%</a:t>
             </a:r>
             <a:endParaRPr lang="en-US" sz="3000" dirty="0"/>
           </a:p>
@@ -2798,7 +2798,7 @@
                 <a:ea typeface="Calibri" pitchFamily="34" charset="-122"/>
                 <a:cs typeface="Calibri" pitchFamily="34" charset="-120"/>
               </a:rPr>
-              <a:t>3</a:t>
+              <a:t>6</a:t>
             </a:r>
             <a:endParaRPr lang="en-US" sz="3000" dirty="0"/>
           </a:p>
@@ -2910,7 +2910,7 @@
                 <a:ea typeface="Calibri" pitchFamily="34" charset="-122"/>
                 <a:cs typeface="Calibri" pitchFamily="34" charset="-120"/>
               </a:rPr>
-              <a:t>2</a:t>
+              <a:t>3</a:t>
             </a:r>
             <a:endParaRPr lang="en-US" sz="3000" dirty="0"/>
           </a:p>
@@ -3022,7 +3022,7 @@
                 <a:ea typeface="Calibri" pitchFamily="34" charset="-122"/>
                 <a:cs typeface="Calibri" pitchFamily="34" charset="-120"/>
               </a:rPr>
-              <a:t>100%</a:t>
+              <a:t>30</a:t>
             </a:r>
             <a:endParaRPr lang="en-US" sz="3000" dirty="0"/>
           </a:p>
@@ -3061,7 +3061,7 @@
                 <a:ea typeface="Calibri" pitchFamily="34" charset="-122"/>
                 <a:cs typeface="Calibri" pitchFamily="34" charset="-120"/>
               </a:rPr>
-              <a:t>Decisions logged &amp; auditable</a:t>
+              <a:t>Products in the live catalogue</a:t>
             </a:r>
             <a:endParaRPr lang="en-US" sz="1400" dirty="0"/>
           </a:p>

</xml_diff>